<commit_message>
Update EU_SAE instructions and dashboard guide
Regenerate and update documentation files: instructions/EU_SAE_Download_Instructions.pdf had metadata and binary stream changes (updated CreationDate/ModDate, adjusted object stream lengths, xref offsets and file ID) — likely a ReportLab regeneration. instructions/EU_SAE_User_Guide_Dashboard_v2.pptx was replaced/updated (binary changes).
</commit_message>
<xml_diff>
--- a/instructions/EU_SAE_User_Guide_Dashboard_v2.pptx
+++ b/instructions/EU_SAE_User_Guide_Dashboard_v2.pptx
@@ -17741,7 +17741,7 @@
                 <a:ea typeface="Calibri" pitchFamily="34" charset="-122"/>
                 <a:cs typeface="Calibri" pitchFamily="34" charset="-120"/>
               </a:rPr>
-              <a:t>Consolidated HTML report - includes run setup, benchmark source, maps, scatter plots, diagnostics, and output locations.</a:t>
+              <a:t>Consolidated HTML report - includes Section 2 Run Setup, maps, scatter plots, diagnostics, and output locations.</a:t>
             </a:r>
             <a:endParaRPr lang="en-US" sz="1050" dirty="0"/>
           </a:p>
@@ -18687,7 +18687,7 @@
                 <a:ea typeface="Calibri" pitchFamily="34" charset="-122"/>
                 <a:cs typeface="Calibri" pitchFamily="34" charset="-120"/>
               </a:rPr>
-              <a:t>Use the Status tab to see the current file path and saved archived copy for each expected output.</a:t>
+              <a:t>Section 2 Run Setup is the audit trail: run ID/label, output folders, benchmark source/level/target, and selected MFH model.</a:t>
             </a:r>
             <a:endParaRPr lang="en-US" sz="1100" dirty="0"/>
           </a:p>

</xml_diff>

<commit_message>
Rename guidance doc; update instruction PDFs/PPTX
Rename 'Guidance Note on Producing Poverty Maps (6_16_2026).docx' to 'guidelines (6_24_2026).docx' to reflect the new version/date, and update instruction assets: replace/modify EU_SAE_Download_Instructions.pdf (PDF content/metadata/pages changed) and EU_SAE_User_Guide_Dashboard_v2.pptx (updated PPTX). These changes align documentation with the latest revisions.
</commit_message>
<xml_diff>
--- a/instructions/EU_SAE_User_Guide_Dashboard_v2.pptx
+++ b/instructions/EU_SAE_User_Guide_Dashboard_v2.pptx
@@ -16586,7 +16586,7 @@
                 <a:ea typeface="Calibri" pitchFamily="34" charset="-122"/>
                 <a:cs typeface="Calibri" pitchFamily="34" charset="-120"/>
               </a:rPr>
-              <a:t>Run the pipeline</a:t>
+              <a:t>Benchmarking option</a:t>
             </a:r>
             <a:endParaRPr lang="en-US" sz="3000" dirty="0"/>
           </a:p>
@@ -16625,7 +16625,7 @@
                 <a:ea typeface="Calibri" pitchFamily="34" charset="-122"/>
                 <a:cs typeface="Calibri" pitchFamily="34" charset="-120"/>
               </a:rPr>
-              <a:t>Tick the steps you want, then click Run Analysis.</a:t>
+              <a:t>After modeling, benchmarking adjusts UFH and MFH estimates so benchmark groups match target rates.</a:t>
             </a:r>
             <a:endParaRPr lang="en-US" sz="1300" dirty="0"/>
           </a:p>
@@ -16735,7 +16735,7 @@
                 <a:ea typeface="Calibri" pitchFamily="34" charset="-122"/>
                 <a:cs typeface="Calibri" pitchFamily="34" charset="-120"/>
               </a:rPr>
-              <a:t>STEP 1</a:t>
+              <a:t>OPTION 1</a:t>
             </a:r>
             <a:endParaRPr lang="en-US" sz="1000" dirty="0"/>
           </a:p>
@@ -16798,7 +16798,7 @@
                 <a:ea typeface="Calibri" pitchFamily="34" charset="-122"/>
                 <a:cs typeface="Calibri" pitchFamily="34" charset="-120"/>
               </a:rPr>
-              <a:t>UFH</a:t>
+              <a:t>Apply benchmarking</a:t>
             </a:r>
             <a:endParaRPr lang="en-US" sz="1800" dirty="0"/>
           </a:p>
@@ -16837,7 +16837,7 @@
                 <a:ea typeface="Calibri" pitchFamily="34" charset="-122"/>
                 <a:cs typeface="Calibri" pitchFamily="34" charset="-120"/>
               </a:rPr>
-              <a:t>Fits one Fay–Herriot model per year. Diagnostics and maps appear in the UFH tab.</a:t>
+              <a:t>Check Apply benchmarking in the sidebar. If unchecked, benchmark uploads and benchmark-level mappings are ignored.</a:t>
             </a:r>
             <a:endParaRPr lang="en-US" sz="1200" dirty="0"/>
           </a:p>
@@ -16947,7 +16947,7 @@
                 <a:ea typeface="Calibri" pitchFamily="34" charset="-122"/>
                 <a:cs typeface="Calibri" pitchFamily="34" charset="-120"/>
               </a:rPr>
-              <a:t>STEP 2</a:t>
+              <a:t>OPTION 2</a:t>
             </a:r>
             <a:endParaRPr lang="en-US" sz="1000" dirty="0"/>
           </a:p>
@@ -17010,7 +17010,7 @@
                 <a:ea typeface="Calibri" pitchFamily="34" charset="-122"/>
                 <a:cs typeface="Calibri" pitchFamily="34" charset="-120"/>
               </a:rPr>
-              <a:t>MFH</a:t>
+              <a:t>Benchmark Target Database</a:t>
             </a:r>
             <a:endParaRPr lang="en-US" sz="1800" dirty="0"/>
           </a:p>
@@ -17049,7 +17049,7 @@
                 <a:ea typeface="Calibri" pitchFamily="34" charset="-122"/>
                 <a:cs typeface="Calibri" pitchFamily="34" charset="-120"/>
               </a:rPr>
-              <a:t>Fits MFH1, MFH2, and (optionally) MFH3 jointly across years. Results in the MFH tab.</a:t>
+              <a:t>Optional targets by year and group. If omitted, targets come from survey direct estimates.</a:t>
             </a:r>
             <a:endParaRPr lang="en-US" sz="1200" dirty="0"/>
           </a:p>
@@ -17159,7 +17159,7 @@
                 <a:ea typeface="Calibri" pitchFamily="34" charset="-122"/>
                 <a:cs typeface="Calibri" pitchFamily="34" charset="-120"/>
               </a:rPr>
-              <a:t>STEP 3</a:t>
+              <a:t>OPTION 3</a:t>
             </a:r>
             <a:endParaRPr lang="en-US" sz="1000" dirty="0"/>
           </a:p>
@@ -17222,7 +17222,7 @@
                 <a:ea typeface="Calibri" pitchFamily="34" charset="-122"/>
                 <a:cs typeface="Calibri" pitchFamily="34" charset="-120"/>
               </a:rPr>
-              <a:t>Comparison</a:t>
+              <a:t>Benchmark level</a:t>
             </a:r>
             <a:endParaRPr lang="en-US" sz="1800" dirty="0"/>
           </a:p>
@@ -17261,7 +17261,7 @@
                 <a:ea typeface="Calibri" pitchFamily="34" charset="-122"/>
                 <a:cs typeface="Calibri" pitchFamily="34" charset="-120"/>
               </a:rPr>
-              <a:t>Merges UFH and MFH side-by-side. Scatter plots, CVs, RMSEs, significance tests.</a:t>
+              <a:t>Leave blank for national benchmarking. Map a column such as region, NUTS2, or voivodeship for grouped benchmarking.</a:t>
             </a:r>
             <a:endParaRPr lang="en-US" sz="1200" dirty="0"/>
           </a:p>

</xml_diff>

<commit_message>
Require data/ folder and improve data resolution
Add explicit data/ folder handling and user-driven file selection across the app. README and UI updated to instruct users to place survey, auxiliary and geometry .rds files in data/ and to pick them in the dashboard. app.R: introduce data_dir_path, resolve_data_input, display_data_path, missing_data_inputs, stronger readiness checks, logging and notifications, and remove implicit fallbacks to packaged sample filenames. Move sample_data files into data/ (renamed auxiliary.rds, shapefile.rds, survey.rds). scripts/*: add %||% helper, existing_default_path and resolve_config_path to robustly resolve configured or legacy paths and prefer packaged defaults when appropriate. Also update packaged instruction PDFs/PPTX.
</commit_message>
<xml_diff>
--- a/instructions/EU_SAE_User_Guide_Dashboard_v2.pptx
+++ b/instructions/EU_SAE_User_Guide_Dashboard_v2.pptx
@@ -11,6 +11,7 @@
     <p:sldId id="256" r:id="rId2"/>
     <p:sldId id="257" r:id="rId3"/>
     <p:sldId id="258" r:id="rId4"/>
+    <p:sldId id="288" r:id="rId37"/>
     <p:sldId id="259" r:id="rId5"/>
     <p:sldId id="287" r:id="rId6"/>
     <p:sldId id="260" r:id="rId7"/>
@@ -133,9 +134,7 @@
     </a:lvl9pPr>
   </p:defaultTextStyle>
   <p:extLst>
-    <p:ext uri="{EFAFB233-063F-42B5-8137-9DF3F51BA10A}">
-      <p15:sldGuideLst xmlns:p15="http://schemas.microsoft.com/office/powerpoint/2012/main"/>
-    </p:ext>
+    <p:ext uri="{EFAFB233-063F-42B5-8137-9DF3F51BA10A}"/>
   </p:extLst>
 </p:presentation>
 </file>
@@ -3818,7 +3817,7 @@
                 <a:ea typeface="Calibri" pitchFamily="34" charset="-122"/>
                 <a:cs typeface="Calibri" pitchFamily="34" charset="-120"/>
               </a:rPr>
-              <a:t>10 / 29</a:t>
+              <a:t>11 / 30</a:t>
             </a:r>
             <a:endParaRPr lang="en-US" sz="900" dirty="0"/>
           </a:p>
@@ -4458,7 +4457,7 @@
                 <a:ea typeface="Consolas" pitchFamily="34" charset="-122"/>
                 <a:cs typeface="Consolas" pitchFamily="34" charset="-120"/>
               </a:rPr>
-              <a:t>├── R/</a:t>
+              <a:t>├── install_packages.R</a:t>
             </a:r>
             <a:endParaRPr lang="en-US" sz="1200" dirty="0"/>
           </a:p>
@@ -4475,7 +4474,7 @@
                 <a:ea typeface="Consolas" pitchFamily="34" charset="-122"/>
                 <a:cs typeface="Consolas" pitchFamily="34" charset="-120"/>
               </a:rPr>
-              <a:t>├── scripts/</a:t>
+              <a:t>├── R/</a:t>
             </a:r>
             <a:endParaRPr lang="en-US" sz="1200" dirty="0"/>
           </a:p>
@@ -4492,7 +4491,7 @@
                 <a:ea typeface="Consolas" pitchFamily="34" charset="-122"/>
                 <a:cs typeface="Consolas" pitchFamily="34" charset="-120"/>
               </a:rPr>
-              <a:t>├── sample_data/</a:t>
+              <a:t>├── scripts/</a:t>
             </a:r>
             <a:endParaRPr lang="en-US" sz="1200" dirty="0"/>
           </a:p>
@@ -4509,7 +4508,41 @@
                 <a:ea typeface="Consolas" pitchFamily="34" charset="-122"/>
                 <a:cs typeface="Consolas" pitchFamily="34" charset="-120"/>
               </a:rPr>
+              <a:t>├── sample_data/</a:t>
+            </a:r>
+            <a:endParaRPr lang="en-US" sz="1200" dirty="0"/>
+          </a:p>
+          <a:p>
+            <a:pPr marL="0" indent="0">
+              <a:buNone/>
+            </a:pPr>
+            <a:r>
+              <a:rPr lang="en-US" sz="1200" dirty="0">
+                <a:solidFill>
+                  <a:srgbClr val="CADCFC"/>
+                </a:solidFill>
+                <a:latin typeface="Consolas" pitchFamily="34" charset="0"/>
+                <a:ea typeface="Consolas" pitchFamily="34" charset="-122"/>
+                <a:cs typeface="Consolas" pitchFamily="34" charset="-120"/>
+              </a:rPr>
               <a:t>├── outputs/</a:t>
+            </a:r>
+            <a:endParaRPr lang="en-US" sz="1200" dirty="0"/>
+          </a:p>
+          <a:p>
+            <a:pPr marL="0" indent="0">
+              <a:buNone/>
+            </a:pPr>
+            <a:r>
+              <a:rPr lang="en-US" sz="1200" dirty="0">
+                <a:solidFill>
+                  <a:srgbClr val="CADCFC"/>
+                </a:solidFill>
+                <a:latin typeface="Consolas" pitchFamily="34" charset="0"/>
+                <a:ea typeface="Consolas" pitchFamily="34" charset="-122"/>
+                <a:cs typeface="Consolas" pitchFamily="34" charset="-120"/>
+              </a:rPr>
+              <a:t>├── instructions/</a:t>
             </a:r>
             <a:endParaRPr lang="en-US" sz="1200" dirty="0"/>
           </a:p>
@@ -4760,7 +4793,7 @@
                 <a:ea typeface="Calibri" pitchFamily="34" charset="-122"/>
                 <a:cs typeface="Calibri" pitchFamily="34" charset="-120"/>
               </a:rPr>
-              <a:t>11 / 29</a:t>
+              <a:t>12 / 30</a:t>
             </a:r>
             <a:endParaRPr lang="en-US" sz="900" dirty="0"/>
           </a:p>
@@ -6073,7 +6106,7 @@
                 <a:ea typeface="Calibri" pitchFamily="34" charset="-122"/>
                 <a:cs typeface="Calibri" pitchFamily="34" charset="-120"/>
               </a:rPr>
-              <a:t>12 / 29</a:t>
+              <a:t>13 / 30</a:t>
             </a:r>
             <a:endParaRPr lang="en-US" sz="900" dirty="0"/>
           </a:p>
@@ -7021,7 +7054,7 @@
                 <a:ea typeface="Calibri" pitchFamily="34" charset="-122"/>
                 <a:cs typeface="Calibri" pitchFamily="34" charset="-120"/>
               </a:rPr>
-              <a:t>13 / 29</a:t>
+              <a:t>14 / 30</a:t>
             </a:r>
             <a:endParaRPr lang="en-US" sz="900" dirty="0"/>
           </a:p>
@@ -7255,7 +7288,7 @@
                 <a:ea typeface="Calibri" pitchFamily="34" charset="-122"/>
                 <a:cs typeface="Calibri" pitchFamily="34" charset="-120"/>
               </a:rPr>
-              <a:t>14 / 29</a:t>
+              <a:t>15 / 30</a:t>
             </a:r>
             <a:endParaRPr lang="en-US" sz="900" dirty="0"/>
           </a:p>
@@ -9247,7 +9280,7 @@
                 <a:ea typeface="Calibri" pitchFamily="34" charset="-122"/>
                 <a:cs typeface="Calibri" pitchFamily="34" charset="-120"/>
               </a:rPr>
-              <a:t>Why two stages?  </a:t>
+              <a:t xml:space="preserve">Why two stages?  </a:t>
             </a:r>
             <a:r>
               <a:rPr lang="en-US" sz="1050" dirty="0">
@@ -9336,7 +9369,7 @@
                 <a:ea typeface="Calibri" pitchFamily="34" charset="-122"/>
                 <a:cs typeface="Calibri" pitchFamily="34" charset="-120"/>
               </a:rPr>
-              <a:t>15 / 29</a:t>
+              <a:t>16 / 30</a:t>
             </a:r>
             <a:endParaRPr lang="en-US" sz="900" dirty="0"/>
           </a:p>
@@ -9602,7 +9635,7 @@
                 <a:ea typeface="Calibri" pitchFamily="34" charset="-122"/>
                 <a:cs typeface="Calibri" pitchFamily="34" charset="-120"/>
               </a:rPr>
-              <a:t>16 / 29</a:t>
+              <a:t>17 / 30</a:t>
             </a:r>
             <a:endParaRPr lang="en-US" sz="900" dirty="0"/>
           </a:p>
@@ -10492,7 +10525,7 @@
                 <a:ea typeface="Calibri" pitchFamily="34" charset="-122"/>
                 <a:cs typeface="Calibri" pitchFamily="34" charset="-120"/>
               </a:rPr>
-              <a:t>Green  </a:t>
+              <a:t xml:space="preserve">Green  </a:t>
             </a:r>
             <a:r>
               <a:rPr lang="en-US" sz="1100" dirty="0">
@@ -10574,7 +10607,7 @@
                 <a:ea typeface="Calibri" pitchFamily="34" charset="-122"/>
                 <a:cs typeface="Calibri" pitchFamily="34" charset="-120"/>
               </a:rPr>
-              <a:t>Amber  </a:t>
+              <a:t xml:space="preserve">Amber  </a:t>
             </a:r>
             <a:r>
               <a:rPr lang="en-US" sz="1100" dirty="0">
@@ -10656,7 +10689,7 @@
                 <a:ea typeface="Calibri" pitchFamily="34" charset="-122"/>
                 <a:cs typeface="Calibri" pitchFamily="34" charset="-120"/>
               </a:rPr>
-              <a:t>Red  </a:t>
+              <a:t xml:space="preserve">Red  </a:t>
             </a:r>
             <a:r>
               <a:rPr lang="en-US" sz="1100" dirty="0">
@@ -10940,7 +10973,7 @@
                 <a:ea typeface="Calibri" pitchFamily="34" charset="-122"/>
                 <a:cs typeface="Calibri" pitchFamily="34" charset="-120"/>
               </a:rPr>
-              <a:t>17 / 29</a:t>
+              <a:t>18 / 30</a:t>
             </a:r>
             <a:endParaRPr lang="en-US" sz="900" dirty="0"/>
           </a:p>
@@ -12350,7 +12383,7 @@
                 <a:ea typeface="Calibri" pitchFamily="34" charset="-122"/>
                 <a:cs typeface="Calibri" pitchFamily="34" charset="-120"/>
               </a:rPr>
-              <a:t>18 / 29</a:t>
+              <a:t>19 / 30</a:t>
             </a:r>
             <a:endParaRPr lang="en-US" sz="900" dirty="0"/>
           </a:p>
@@ -13627,7 +13660,7 @@
                 <a:ea typeface="Calibri" pitchFamily="34" charset="-122"/>
                 <a:cs typeface="Calibri" pitchFamily="34" charset="-120"/>
               </a:rPr>
-              <a:t>Rule of thumb  </a:t>
+              <a:t xml:space="preserve">Rule of thumb  </a:t>
             </a:r>
             <a:r>
               <a:rPr lang="en-US" sz="1100" dirty="0">
@@ -13872,7 +13905,7 @@
                 <a:ea typeface="Calibri" pitchFamily="34" charset="-122"/>
                 <a:cs typeface="Calibri" pitchFamily="34" charset="-120"/>
               </a:rPr>
-              <a:t>19 / 29</a:t>
+              <a:t>20 / 30</a:t>
             </a:r>
             <a:endParaRPr lang="en-US" sz="900" dirty="0"/>
           </a:p>
@@ -15360,7 +15393,7 @@
                 <a:ea typeface="Calibri" pitchFamily="34" charset="-122"/>
                 <a:cs typeface="Calibri" pitchFamily="34" charset="-120"/>
               </a:rPr>
-              <a:t>MFH2 is the default  </a:t>
+              <a:t xml:space="preserve">MFH2 is the default  </a:t>
             </a:r>
             <a:r>
               <a:rPr lang="en-US" sz="1100" dirty="0">
@@ -15605,7 +15638,7 @@
                 <a:ea typeface="Calibri" pitchFamily="34" charset="-122"/>
                 <a:cs typeface="Calibri" pitchFamily="34" charset="-120"/>
               </a:rPr>
-              <a:t>2 / 29</a:t>
+              <a:t>2 / 30</a:t>
             </a:r>
             <a:endParaRPr lang="en-US" sz="900" dirty="0"/>
           </a:p>
@@ -16547,7 +16580,7 @@
                 <a:ea typeface="Calibri" pitchFamily="34" charset="-122"/>
                 <a:cs typeface="Calibri" pitchFamily="34" charset="-120"/>
               </a:rPr>
-              <a:t>20 / 29</a:t>
+              <a:t>21 / 30</a:t>
             </a:r>
             <a:endParaRPr lang="en-US" sz="900" dirty="0"/>
           </a:p>
@@ -17495,7 +17528,7 @@
                 <a:ea typeface="Calibri" pitchFamily="34" charset="-122"/>
                 <a:cs typeface="Calibri" pitchFamily="34" charset="-120"/>
               </a:rPr>
-              <a:t>21 / 29</a:t>
+              <a:t>22 / 30</a:t>
             </a:r>
             <a:endParaRPr lang="en-US" sz="900" dirty="0"/>
           </a:p>
@@ -18676,7 +18709,7 @@
                 <a:ea typeface="Calibri" pitchFamily="34" charset="-122"/>
                 <a:cs typeface="Calibri" pitchFamily="34" charset="-120"/>
               </a:rPr>
-              <a:t>Note  </a:t>
+              <a:t xml:space="preserve">Note  </a:t>
             </a:r>
             <a:r>
               <a:rPr lang="en-US" sz="1100" dirty="0">
@@ -18955,7 +18988,7 @@
                 <a:ea typeface="Calibri" pitchFamily="34" charset="-122"/>
                 <a:cs typeface="Calibri" pitchFamily="34" charset="-120"/>
               </a:rPr>
-              <a:t>22 / 29</a:t>
+              <a:t>23 / 30</a:t>
             </a:r>
             <a:endParaRPr lang="en-US" sz="900" dirty="0"/>
           </a:p>
@@ -19189,7 +19222,7 @@
                 <a:ea typeface="Calibri" pitchFamily="34" charset="-122"/>
                 <a:cs typeface="Calibri" pitchFamily="34" charset="-120"/>
               </a:rPr>
-              <a:t>23 / 29</a:t>
+              <a:t>24 / 30</a:t>
             </a:r>
             <a:endParaRPr lang="en-US" sz="900" dirty="0"/>
           </a:p>
@@ -19866,7 +19899,7 @@
                 <a:ea typeface="Calibri" pitchFamily="34" charset="-122"/>
                 <a:cs typeface="Calibri" pitchFamily="34" charset="-120"/>
               </a:rPr>
-              <a:t>Privacy  </a:t>
+              <a:t xml:space="preserve">Privacy  </a:t>
             </a:r>
             <a:r>
               <a:rPr lang="en-US" sz="1200" dirty="0">
@@ -20111,7 +20144,7 @@
                 <a:ea typeface="Calibri" pitchFamily="34" charset="-122"/>
                 <a:cs typeface="Calibri" pitchFamily="34" charset="-120"/>
               </a:rPr>
-              <a:t>24 / 29</a:t>
+              <a:t>25 / 30</a:t>
             </a:r>
             <a:endParaRPr lang="en-US" sz="900" dirty="0"/>
           </a:p>
@@ -21249,7 +21282,7 @@
                 <a:ea typeface="Calibri" pitchFamily="34" charset="-122"/>
                 <a:cs typeface="Calibri" pitchFamily="34" charset="-120"/>
               </a:rPr>
-              <a:t>25 / 29</a:t>
+              <a:t>26 / 30</a:t>
             </a:r>
             <a:endParaRPr lang="en-US" sz="900" dirty="0"/>
           </a:p>
@@ -22387,7 +22420,7 @@
                 <a:ea typeface="Calibri" pitchFamily="34" charset="-122"/>
                 <a:cs typeface="Calibri" pitchFamily="34" charset="-120"/>
               </a:rPr>
-              <a:t>26 / 29</a:t>
+              <a:t>27 / 30</a:t>
             </a:r>
             <a:endParaRPr lang="en-US" sz="900" dirty="0"/>
           </a:p>
@@ -23872,7 +23905,7 @@
                 <a:ea typeface="Calibri" pitchFamily="34" charset="-122"/>
                 <a:cs typeface="Calibri" pitchFamily="34" charset="-120"/>
               </a:rPr>
-              <a:t>27 / 29</a:t>
+              <a:t>28 / 30</a:t>
             </a:r>
             <a:endParaRPr lang="en-US" sz="900" dirty="0"/>
           </a:p>
@@ -26140,7 +26173,7 @@
                 <a:ea typeface="Calibri" pitchFamily="34" charset="-122"/>
                 <a:cs typeface="Calibri" pitchFamily="34" charset="-120"/>
               </a:rPr>
-              <a:t>28 / 29</a:t>
+              <a:t>29 / 30</a:t>
             </a:r>
             <a:endParaRPr lang="en-US" sz="900" dirty="0"/>
           </a:p>
@@ -28242,7 +28275,7 @@
                 <a:ea typeface="Calibri" pitchFamily="34" charset="-122"/>
                 <a:cs typeface="Calibri" pitchFamily="34" charset="-120"/>
               </a:rPr>
-              <a:t>3 / 29</a:t>
+              <a:t>3 / 30</a:t>
             </a:r>
             <a:endParaRPr lang="en-US" sz="900" dirty="0"/>
           </a:p>
@@ -28401,7 +28434,7 @@
                 <a:ea typeface="Calibri" pitchFamily="34" charset="-122"/>
                 <a:cs typeface="Calibri" pitchFamily="34" charset="-120"/>
               </a:rPr>
-              <a:t>You will </a:t>
+              <a:t xml:space="preserve">You will </a:t>
             </a:r>
             <a:r>
               <a:rPr lang="en-US" sz="1300" b="1" dirty="0">
@@ -28423,7 +28456,7 @@
                 <a:ea typeface="Calibri" pitchFamily="34" charset="-122"/>
                 <a:cs typeface="Calibri" pitchFamily="34" charset="-120"/>
               </a:rPr>
-              <a:t> survey, auxiliary, and geometry data, </a:t>
+              <a:t xml:space="preserve"> survey, auxiliary, and geometry data, </a:t>
             </a:r>
             <a:r>
               <a:rPr lang="en-US" sz="1300" b="1" dirty="0">
@@ -28445,7 +28478,7 @@
                 <a:ea typeface="Calibri" pitchFamily="34" charset="-122"/>
                 <a:cs typeface="Calibri" pitchFamily="34" charset="-120"/>
               </a:rPr>
-              <a:t> Fay–Herriot models (UFH and MFH), </a:t>
+              <a:t xml:space="preserve"> Fay–Herriot models (UFH and MFH), </a:t>
             </a:r>
             <a:r>
               <a:rPr lang="en-US" sz="1300" b="1" dirty="0">
@@ -28467,7 +28500,7 @@
                 <a:ea typeface="Calibri" pitchFamily="34" charset="-122"/>
                 <a:cs typeface="Calibri" pitchFamily="34" charset="-120"/>
               </a:rPr>
-              <a:t> results side-by-side with maps and tables, and optionally </a:t>
+              <a:t xml:space="preserve"> results side-by-side with maps and tables, and optionally </a:t>
             </a:r>
             <a:r>
               <a:rPr lang="en-US" sz="1300" b="1" dirty="0">
@@ -28489,7 +28522,7 @@
                 <a:ea typeface="Calibri" pitchFamily="34" charset="-122"/>
                 <a:cs typeface="Calibri" pitchFamily="34" charset="-120"/>
               </a:rPr>
-              <a:t> AI-assisted interpretation.</a:t>
+              <a:t xml:space="preserve"> AI-assisted interpretation.</a:t>
             </a:r>
             <a:endParaRPr lang="en-US" sz="1300" dirty="0"/>
           </a:p>
@@ -29238,6 +29271,1074 @@
         </ns0:txBody>
       </ns0:sp>
     </ns0:spTree>
+  </ns0:cSld>
+  <ns0:clrMapOvr>
+    <a:masterClrMapping/>
+  </ns0:clrMapOvr>
+</ns0:sld>
+</file>
+
+<file path=ppt/slides/slide30.xml><?xml version="1.0" encoding="utf-8"?>
+<ns0:sld xmlns:a="http://schemas.openxmlformats.org/drawingml/2006/main" xmlns:ns0="http://schemas.openxmlformats.org/presentationml/2006/main" xmlns:ns2="http://schemas.openxmlformats.org/officeDocument/2006/relationships" xmlns:ns3="http://schemas.microsoft.com/office/drawing/2014/main" xmlns:ns4="http://schemas.microsoft.com/office/powerpoint/2010/main">
+  <ns0:cSld>
+    <ns0:spTree>
+      <ns0:nvGrpSpPr>
+        <ns0:cNvPr id="1" name=""/>
+        <ns0:cNvGrpSpPr/>
+        <ns0:nvPr/>
+      </ns0:nvGrpSpPr>
+      <ns0:grpSpPr>
+        <a:xfrm>
+          <a:off x="0" y="0"/>
+          <a:ext cx="0" cy="0"/>
+          <a:chOff x="0" y="0"/>
+          <a:chExt cx="0" cy="0"/>
+        </a:xfrm>
+      </ns0:grpSpPr>
+      <ns0:sp>
+        <ns0:nvSpPr>
+          <ns0:cNvPr id="2" name="Shape 0"/>
+          <ns0:cNvSpPr/>
+          <ns0:nvPr/>
+        </ns0:nvSpPr>
+        <ns0:spPr>
+          <a:xfrm>
+            <a:off x="0" y="0"/>
+            <a:ext cx="109728" cy="5143500"/>
+          </a:xfrm>
+          <a:prstGeom prst="rect">
+            <a:avLst/>
+          </a:prstGeom>
+          <a:solidFill>
+            <a:srgbClr val="15284F"/>
+          </a:solidFill>
+          <a:ln/>
+        </ns0:spPr>
+        <ns0:txBody>
+          <a:bodyPr/>
+          <a:lstStyle/>
+          <a:p>
+            <a:endParaRPr lang="en-US"/>
+          </a:p>
+        </ns0:txBody>
+      </ns0:sp>
+      <ns0:sp>
+        <ns0:nvSpPr>
+          <ns0:cNvPr id="3" name="Shape 1"/>
+          <ns0:cNvSpPr/>
+          <ns0:nvPr/>
+        </ns0:nvSpPr>
+        <ns0:spPr>
+          <a:xfrm>
+            <a:off x="0" y="0"/>
+            <a:ext cx="109728" cy="1005840"/>
+          </a:xfrm>
+          <a:prstGeom prst="rect">
+            <a:avLst/>
+          </a:prstGeom>
+          <a:solidFill>
+            <a:srgbClr val="6AA7D9"/>
+          </a:solidFill>
+          <a:ln/>
+        </ns0:spPr>
+        <ns0:txBody>
+          <a:bodyPr/>
+          <a:lstStyle/>
+          <a:p>
+            <a:endParaRPr lang="en-US"/>
+          </a:p>
+        </ns0:txBody>
+      </ns0:sp>
+      <ns0:sp>
+        <ns0:nvSpPr>
+          <ns0:cNvPr id="5" name="Shape 3"/>
+          <ns0:cNvSpPr/>
+          <ns0:nvPr/>
+        </ns0:nvSpPr>
+        <ns0:spPr>
+          <a:xfrm>
+            <a:off x="502920" y="4732020"/>
+            <a:ext cx="8138160" cy="0"/>
+          </a:xfrm>
+          <a:prstGeom prst="line">
+            <a:avLst/>
+          </a:prstGeom>
+          <a:noFill/>
+          <a:ln w="9525">
+            <a:solidFill>
+              <a:srgbClr val="DCE4F0"/>
+            </a:solidFill>
+            <a:prstDash val="solid"/>
+          </a:ln>
+        </ns0:spPr>
+        <ns0:txBody>
+          <a:bodyPr/>
+          <a:lstStyle/>
+          <a:p>
+            <a:endParaRPr lang="en-US"/>
+          </a:p>
+        </ns0:txBody>
+      </ns0:sp>
+      <ns0:sp>
+        <ns0:nvSpPr>
+          <ns0:cNvPr id="6" name="Text 4"/>
+          <ns0:cNvSpPr/>
+          <ns0:nvPr/>
+        </ns0:nvSpPr>
+        <ns0:spPr>
+          <a:xfrm>
+            <a:off x="502920" y="4796028"/>
+            <a:ext cx="4572000" cy="256032"/>
+          </a:xfrm>
+          <a:prstGeom prst="rect">
+            <a:avLst/>
+          </a:prstGeom>
+          <a:noFill/>
+          <a:ln/>
+        </ns0:spPr>
+        <ns0:txBody>
+          <a:bodyPr wrap="square" lIns="0" tIns="0" rIns="0" bIns="0" rtlCol="0" anchor="ctr"/>
+          <a:lstStyle/>
+          <a:p>
+            <a:pPr marL="0" indent="0">
+              <a:buNone/>
+            </a:pPr>
+            <a:r>
+              <a:rPr lang="en-US" sz="900" dirty="0">
+                <a:solidFill>
+                  <a:srgbClr val="7A8CAE"/>
+                </a:solidFill>
+                <a:latin typeface="Calibri" pitchFamily="34" charset="0"/>
+                <a:ea typeface="Calibri" pitchFamily="34" charset="-122"/>
+                <a:cs typeface="Calibri" pitchFamily="34" charset="-120"/>
+              </a:rPr>
+              <a:t>EU SAE Dashboard  ·  User Guide</a:t>
+            </a:r>
+            <a:endParaRPr lang="en-US" sz="900" dirty="0"/>
+          </a:p>
+        </ns0:txBody>
+      </ns0:sp>
+      <ns0:sp>
+        <ns0:nvSpPr>
+          <ns0:cNvPr id="7" name="Text 5"/>
+          <ns0:cNvSpPr/>
+          <ns0:nvPr/>
+        </ns0:nvSpPr>
+        <ns0:spPr>
+          <a:xfrm>
+            <a:off x="7680960" y="4796028"/>
+            <a:ext cx="960120" cy="256032"/>
+          </a:xfrm>
+          <a:prstGeom prst="rect">
+            <a:avLst/>
+          </a:prstGeom>
+          <a:noFill/>
+          <a:ln/>
+        </ns0:spPr>
+        <ns0:txBody>
+          <a:bodyPr wrap="square" lIns="0" tIns="0" rIns="0" bIns="0" rtlCol="0" anchor="ctr"/>
+          <a:lstStyle/>
+          <a:p>
+            <a:pPr marL="0" indent="0" algn="r">
+              <a:buNone/>
+            </a:pPr>
+            <a:r>
+              <a:rPr lang="en-US" sz="900" dirty="0">
+                <a:solidFill>
+                  <a:srgbClr val="7A8CAE"/>
+                </a:solidFill>
+                <a:latin typeface="Calibri" pitchFamily="34" charset="0"/>
+                <a:ea typeface="Calibri" pitchFamily="34" charset="-122"/>
+                <a:cs typeface="Calibri" pitchFamily="34" charset="-120"/>
+              </a:rPr>
+              <a:t>4 / 30</a:t>
+            </a:r>
+            <a:endParaRPr lang="en-US" sz="900" dirty="0"/>
+          </a:p>
+        </ns0:txBody>
+      </ns0:sp>
+      <ns0:sp>
+        <ns0:nvSpPr>
+          <ns0:cNvPr id="8" name="Text 6"/>
+          <ns0:cNvSpPr/>
+          <ns0:nvPr/>
+        </ns0:nvSpPr>
+        <ns0:spPr>
+          <a:xfrm>
+            <a:off x="502920" y="640080"/>
+            <a:ext cx="8138160" cy="640080"/>
+          </a:xfrm>
+          <a:prstGeom prst="rect">
+            <a:avLst/>
+          </a:prstGeom>
+          <a:noFill/>
+          <a:ln/>
+        </ns0:spPr>
+        <ns0:txBody>
+          <a:bodyPr wrap="square" lIns="0" tIns="0" rIns="0" bIns="0" rtlCol="0" anchor="ctr"/>
+          <a:lstStyle/>
+          <a:p>
+            <a:pPr marL="0" indent="0">
+              <a:buNone/>
+            </a:pPr>
+            <a:r>
+              <a:rPr lang="en-US" sz="3000" b="1" dirty="0">
+                <a:solidFill>
+                  <a:srgbClr val="0F1E3F"/>
+                </a:solidFill>
+                <a:latin typeface="Calibri" pitchFamily="34" charset="0"/>
+                <a:ea typeface="Calibri" pitchFamily="34" charset="-122"/>
+                <a:cs typeface="Calibri" pitchFamily="34" charset="-120"/>
+              </a:rPr>
+              <a:t>What you can estimate</a:t>
+            </a:r>
+            <a:endParaRPr lang="en-US" sz="3000" dirty="0"/>
+          </a:p>
+        </ns0:txBody>
+      </ns0:sp>
+      <ns0:sp>
+        <ns0:nvSpPr>
+          <ns0:cNvPr id="9" name="Text 7"/>
+          <ns0:cNvSpPr/>
+          <ns0:nvPr/>
+        </ns0:nvSpPr>
+        <ns0:spPr>
+          <a:xfrm>
+            <a:off x="502920" y="1234440"/>
+            <a:ext cx="8138160" cy="347472"/>
+          </a:xfrm>
+          <a:prstGeom prst="rect">
+            <a:avLst/>
+          </a:prstGeom>
+          <a:noFill/>
+          <a:ln/>
+        </ns0:spPr>
+        <ns0:txBody>
+          <a:bodyPr wrap="square" lIns="0" tIns="0" rIns="0" bIns="0" rtlCol="0" anchor="ctr"/>
+          <a:lstStyle/>
+          <a:p>
+            <a:pPr marL="0" indent="0">
+              <a:buNone/>
+            </a:pPr>
+            <a:r>
+              <a:rPr lang="en-US" sz="1300" dirty="0">
+                <a:solidFill>
+                  <a:srgbClr val="43578A"/>
+                </a:solidFill>
+                <a:latin typeface="Calibri" pitchFamily="34" charset="0"/>
+                <a:ea typeface="Calibri" pitchFamily="34" charset="-122"/>
+                <a:cs typeface="Calibri" pitchFamily="34" charset="-120"/>
+              </a:rPr>
+              <a:t>Three indicator families, all from the same survey-plus-auxiliary inputs.</a:t>
+            </a:r>
+            <a:endParaRPr lang="en-US" sz="1300" dirty="0"/>
+          </a:p>
+        </ns0:txBody>
+      </ns0:sp>
+      <ns0:sp>
+        <ns0:nvSpPr>
+          <ns0:cNvPr id="10" name="Shape 8"/>
+          <ns0:cNvSpPr/>
+          <ns0:nvPr/>
+        </ns0:nvSpPr>
+        <ns0:spPr>
+          <a:xfrm>
+            <a:off x="502920" y="1828800"/>
+            <a:ext cx="2590800" cy="2743200"/>
+          </a:xfrm>
+          <a:prstGeom prst="rect">
+            <a:avLst/>
+          </a:prstGeom>
+          <a:solidFill>
+            <a:srgbClr val="FFFFFF"/>
+          </a:solidFill>
+          <a:ln w="9525">
+            <a:solidFill>
+              <a:srgbClr val="DCE4F0"/>
+            </a:solidFill>
+            <a:prstDash val="solid"/>
+          </a:ln>
+          <a:effectLst>
+            <a:outerShdw blurRad="76200" dist="12700" dir="5400000" algn="bl" rotWithShape="0">
+              <a:srgbClr val="1F3669">
+                <a:alpha val="5000"/>
+              </a:srgbClr>
+            </a:outerShdw>
+          </a:effectLst>
+        </ns0:spPr>
+        <ns0:txBody>
+          <a:bodyPr/>
+          <a:lstStyle/>
+          <a:p>
+            <a:endParaRPr lang="en-US"/>
+          </a:p>
+        </ns0:txBody>
+      </ns0:sp>
+      <ns0:sp>
+        <ns0:nvSpPr>
+          <ns0:cNvPr id="11" name="Shape 9"/>
+          <ns0:cNvSpPr/>
+          <ns0:nvPr/>
+        </ns0:nvSpPr>
+        <ns0:spPr>
+          <a:xfrm>
+            <a:off x="502920" y="1828800"/>
+            <a:ext cx="2590800" cy="685800"/>
+          </a:xfrm>
+          <a:prstGeom prst="rect">
+            <a:avLst/>
+          </a:prstGeom>
+          <a:solidFill>
+            <a:srgbClr val="15284F"/>
+          </a:solidFill>
+          <a:ln w="12700">
+            <a:solidFill>
+              <a:srgbClr val="15284F"/>
+            </a:solidFill>
+            <a:prstDash val="solid"/>
+          </a:ln>
+        </ns0:spPr>
+        <ns0:txBody>
+          <a:bodyPr/>
+          <a:lstStyle/>
+          <a:p>
+            <a:endParaRPr lang="en-US"/>
+          </a:p>
+        </ns0:txBody>
+      </ns0:sp>
+      <ns0:sp>
+        <ns0:nvSpPr>
+          <ns0:cNvPr id="12" name="Text 10"/>
+          <ns0:cNvSpPr/>
+          <ns0:nvPr/>
+        </ns0:nvSpPr>
+        <ns0:spPr>
+          <a:xfrm>
+            <a:off x="777240" y="1920240"/>
+            <a:ext cx="2133600" cy="228600"/>
+          </a:xfrm>
+          <a:prstGeom prst="rect">
+            <a:avLst/>
+          </a:prstGeom>
+          <a:noFill/>
+          <a:ln/>
+        </ns0:spPr>
+        <ns0:txBody>
+          <a:bodyPr wrap="square" lIns="0" tIns="0" rIns="0" bIns="0" rtlCol="0" anchor="ctr"/>
+          <a:lstStyle/>
+          <a:p>
+            <a:pPr marL="0" indent="0">
+              <a:buNone/>
+            </a:pPr>
+            <a:r>
+              <a:rPr lang="en-US" sz="1000" b="1" kern="0" spc="400" dirty="0">
+                <a:solidFill>
+                  <a:srgbClr val="6AA7D9"/>
+                </a:solidFill>
+                <a:latin typeface="Calibri" pitchFamily="34" charset="0"/>
+                <a:ea typeface="Calibri" pitchFamily="34" charset="-122"/>
+                <a:cs typeface="Calibri" pitchFamily="34" charset="-120"/>
+              </a:rPr>
+              <a:t>INDICATOR 1</a:t>
+            </a:r>
+            <a:endParaRPr lang="en-US" sz="1000" dirty="0"/>
+          </a:p>
+        </ns0:txBody>
+      </ns0:sp>
+      <ns0:sp>
+        <ns0:nvSpPr>
+          <ns0:cNvPr id="13" name="Text 11"/>
+          <ns0:cNvSpPr/>
+          <ns0:nvPr/>
+        </ns0:nvSpPr>
+        <ns0:spPr>
+          <a:xfrm>
+            <a:off x="777240" y="2139696"/>
+            <a:ext cx="2133600" cy="310896"/>
+          </a:xfrm>
+          <a:prstGeom prst="rect">
+            <a:avLst/>
+          </a:prstGeom>
+          <a:noFill/>
+          <a:ln/>
+        </ns0:spPr>
+        <ns0:txBody>
+          <a:bodyPr wrap="square" lIns="0" tIns="0" rIns="0" bIns="0" rtlCol="0" anchor="ctr"/>
+          <a:lstStyle/>
+          <a:p>
+            <a:pPr marL="0" indent="0">
+              <a:buNone/>
+            </a:pPr>
+            <a:r>
+              <a:rPr lang="en-US" sz="1800" b="1" dirty="0">
+                <a:solidFill>
+                  <a:srgbClr val="FFFFFF"/>
+                </a:solidFill>
+                <a:latin typeface="Calibri" pitchFamily="34" charset="0"/>
+                <a:ea typeface="Calibri" pitchFamily="34" charset="-122"/>
+                <a:cs typeface="Calibri" pitchFamily="34" charset="-120"/>
+              </a:rPr>
+              <a:t>Poverty rate</a:t>
+            </a:r>
+            <a:endParaRPr lang="en-US" sz="1800" dirty="0"/>
+          </a:p>
+        </ns0:txBody>
+      </ns0:sp>
+      <ns0:pic>
+        <ns0:nvPicPr>
+          <ns0:cNvPr id="14" name="Image 0" descr="preencoded.png"/>
+          <ns0:cNvPicPr>
+            <a:picLocks noChangeAspect="1"/>
+          </ns0:cNvPicPr>
+          <ns0:nvPr/>
+        </ns0:nvPicPr>
+        <ns0:blipFill>
+          <a:blip ns2:embed="rId2"/>
+          <a:stretch>
+            <a:fillRect/>
+          </a:stretch>
+        </ns0:blipFill>
+        <ns0:spPr>
+          <a:xfrm>
+            <a:off x="2471928" y="2697480"/>
+            <a:ext cx="329184" cy="329184"/>
+          </a:xfrm>
+          <a:prstGeom prst="rect">
+            <a:avLst/>
+          </a:prstGeom>
+        </ns0:spPr>
+      </ns0:pic>
+      <ns0:sp>
+        <ns0:nvSpPr>
+          <ns0:cNvPr id="15" name="Text 12"/>
+          <ns0:cNvSpPr/>
+          <ns0:nvPr/>
+        </ns0:nvSpPr>
+        <ns0:spPr>
+          <a:xfrm>
+            <a:off x="777240" y="2697480"/>
+            <a:ext cx="1722120" cy="310896"/>
+          </a:xfrm>
+          <a:prstGeom prst="rect">
+            <a:avLst/>
+          </a:prstGeom>
+          <a:noFill/>
+          <a:ln/>
+        </ns0:spPr>
+        <ns0:txBody>
+          <a:bodyPr wrap="square" lIns="0" tIns="0" rIns="0" bIns="0" rtlCol="0" anchor="ctr"/>
+          <a:lstStyle/>
+          <a:p>
+            <a:pPr marL="0" indent="0">
+              <a:buNone/>
+            </a:pPr>
+            <a:r>
+              <a:rPr lang="en-US" sz="1200" b="1" dirty="0">
+                <a:solidFill>
+                  <a:srgbClr val="0F1E3F"/>
+                </a:solidFill>
+                <a:latin typeface="Calibri" pitchFamily="34" charset="0"/>
+                <a:ea typeface="Calibri" pitchFamily="34" charset="-122"/>
+                <a:cs typeface="Calibri" pitchFamily="34" charset="-120"/>
+              </a:rPr>
+              <a:t>FGT(0) · headcount</a:t>
+            </a:r>
+            <a:endParaRPr lang="en-US" sz="1200" dirty="0"/>
+          </a:p>
+        </ns0:txBody>
+      </ns0:sp>
+      <ns0:sp>
+        <ns0:nvSpPr>
+          <ns0:cNvPr id="16" name="Text 13"/>
+          <ns0:cNvSpPr/>
+          <ns0:nvPr/>
+        </ns0:nvSpPr>
+        <ns0:spPr>
+          <a:xfrm>
+            <a:off x="777240" y="3108960"/>
+            <a:ext cx="2133600" cy="1280160"/>
+          </a:xfrm>
+          <a:prstGeom prst="rect">
+            <a:avLst/>
+          </a:prstGeom>
+          <a:noFill/>
+          <a:ln/>
+        </ns0:spPr>
+        <ns0:txBody>
+          <a:bodyPr wrap="square" lIns="0" tIns="0" rIns="0" bIns="0" rtlCol="0" anchor="ctr"/>
+          <a:lstStyle/>
+          <a:p>
+            <a:pPr marL="0" indent="0">
+              <a:buNone/>
+            </a:pPr>
+            <a:r>
+              <a:rPr lang="en-US" sz="1150" dirty="0">
+                <a:solidFill>
+                  <a:srgbClr val="43578A"/>
+                </a:solidFill>
+                <a:latin typeface="Calibri" pitchFamily="34" charset="0"/>
+                <a:ea typeface="Calibri" pitchFamily="34" charset="-122"/>
+                <a:cs typeface="Calibri" pitchFamily="34" charset="-120"/>
+              </a:rPr>
+              <a:t>Share of the population below the poverty line — the standard poverty rate.</a:t>
+            </a:r>
+            <a:endParaRPr lang="en-US" sz="1150" dirty="0"/>
+          </a:p>
+        </ns0:txBody>
+      </ns0:sp>
+      <ns0:sp>
+        <ns0:nvSpPr>
+          <ns0:cNvPr id="17" name="Shape 14"/>
+          <ns0:cNvSpPr/>
+          <ns0:nvPr/>
+        </ns0:nvSpPr>
+        <ns0:spPr>
+          <a:xfrm>
+            <a:off x="3276600" y="1828800"/>
+            <a:ext cx="2590800" cy="2743200"/>
+          </a:xfrm>
+          <a:prstGeom prst="rect">
+            <a:avLst/>
+          </a:prstGeom>
+          <a:solidFill>
+            <a:srgbClr val="FFFFFF"/>
+          </a:solidFill>
+          <a:ln w="9525">
+            <a:solidFill>
+              <a:srgbClr val="DCE4F0"/>
+            </a:solidFill>
+            <a:prstDash val="solid"/>
+          </a:ln>
+          <a:effectLst>
+            <a:outerShdw blurRad="76200" dist="12700" dir="5400000" algn="bl" rotWithShape="0">
+              <a:srgbClr val="1F3669">
+                <a:alpha val="5000"/>
+              </a:srgbClr>
+            </a:outerShdw>
+          </a:effectLst>
+        </ns0:spPr>
+        <ns0:txBody>
+          <a:bodyPr/>
+          <a:lstStyle/>
+          <a:p>
+            <a:endParaRPr lang="en-US"/>
+          </a:p>
+        </ns0:txBody>
+      </ns0:sp>
+      <ns0:sp>
+        <ns0:nvSpPr>
+          <ns0:cNvPr id="18" name="Shape 15"/>
+          <ns0:cNvSpPr/>
+          <ns0:nvPr/>
+        </ns0:nvSpPr>
+        <ns0:spPr>
+          <a:xfrm>
+            <a:off x="3276600" y="1828800"/>
+            <a:ext cx="2590800" cy="685800"/>
+          </a:xfrm>
+          <a:prstGeom prst="rect">
+            <a:avLst/>
+          </a:prstGeom>
+          <a:solidFill>
+            <a:srgbClr val="15284F"/>
+          </a:solidFill>
+          <a:ln w="12700">
+            <a:solidFill>
+              <a:srgbClr val="15284F"/>
+            </a:solidFill>
+            <a:prstDash val="solid"/>
+          </a:ln>
+        </ns0:spPr>
+        <ns0:txBody>
+          <a:bodyPr/>
+          <a:lstStyle/>
+          <a:p>
+            <a:endParaRPr lang="en-US"/>
+          </a:p>
+        </ns0:txBody>
+      </ns0:sp>
+      <ns0:sp>
+        <ns0:nvSpPr>
+          <ns0:cNvPr id="19" name="Text 16"/>
+          <ns0:cNvSpPr/>
+          <ns0:nvPr/>
+        </ns0:nvSpPr>
+        <ns0:spPr>
+          <a:xfrm>
+            <a:off x="3550920" y="1920240"/>
+            <a:ext cx="2133600" cy="228600"/>
+          </a:xfrm>
+          <a:prstGeom prst="rect">
+            <a:avLst/>
+          </a:prstGeom>
+          <a:noFill/>
+          <a:ln/>
+        </ns0:spPr>
+        <ns0:txBody>
+          <a:bodyPr wrap="square" lIns="0" tIns="0" rIns="0" bIns="0" rtlCol="0" anchor="ctr"/>
+          <a:lstStyle/>
+          <a:p>
+            <a:pPr marL="0" indent="0">
+              <a:buNone/>
+            </a:pPr>
+            <a:r>
+              <a:rPr lang="en-US" sz="1000" b="1" kern="0" spc="400" dirty="0">
+                <a:solidFill>
+                  <a:srgbClr val="6AA7D9"/>
+                </a:solidFill>
+                <a:latin typeface="Calibri" pitchFamily="34" charset="0"/>
+                <a:ea typeface="Calibri" pitchFamily="34" charset="-122"/>
+                <a:cs typeface="Calibri" pitchFamily="34" charset="-120"/>
+              </a:rPr>
+              <a:t>INDICATOR 2</a:t>
+            </a:r>
+            <a:endParaRPr lang="en-US" sz="1000" dirty="0"/>
+          </a:p>
+        </ns0:txBody>
+      </ns0:sp>
+      <ns0:sp>
+        <ns0:nvSpPr>
+          <ns0:cNvPr id="20" name="Text 17"/>
+          <ns0:cNvSpPr/>
+          <ns0:nvPr/>
+        </ns0:nvSpPr>
+        <ns0:spPr>
+          <a:xfrm>
+            <a:off x="3550920" y="2139696"/>
+            <a:ext cx="2133600" cy="310896"/>
+          </a:xfrm>
+          <a:prstGeom prst="rect">
+            <a:avLst/>
+          </a:prstGeom>
+          <a:noFill/>
+          <a:ln/>
+        </ns0:spPr>
+        <ns0:txBody>
+          <a:bodyPr wrap="square" lIns="0" tIns="0" rIns="0" bIns="0" rtlCol="0" anchor="ctr"/>
+          <a:lstStyle/>
+          <a:p>
+            <a:pPr marL="0" indent="0">
+              <a:buNone/>
+            </a:pPr>
+            <a:r>
+              <a:rPr lang="en-US" sz="1800" b="1" dirty="0">
+                <a:solidFill>
+                  <a:srgbClr val="FFFFFF"/>
+                </a:solidFill>
+                <a:latin typeface="Calibri" pitchFamily="34" charset="0"/>
+                <a:ea typeface="Calibri" pitchFamily="34" charset="-122"/>
+                <a:cs typeface="Calibri" pitchFamily="34" charset="-120"/>
+              </a:rPr>
+              <a:t>Gap &amp; severity</a:t>
+            </a:r>
+            <a:endParaRPr lang="en-US" sz="1800" dirty="0"/>
+          </a:p>
+        </ns0:txBody>
+      </ns0:sp>
+      <ns0:pic>
+        <ns0:nvPicPr>
+          <ns0:cNvPr id="21" name="Image 1" descr="preencoded.png"/>
+          <ns0:cNvPicPr>
+            <a:picLocks noChangeAspect="1"/>
+          </ns0:cNvPicPr>
+          <ns0:nvPr/>
+        </ns0:nvPicPr>
+        <ns0:blipFill>
+          <a:blip ns2:embed="rId3"/>
+          <a:stretch>
+            <a:fillRect/>
+          </a:stretch>
+        </ns0:blipFill>
+        <ns0:spPr>
+          <a:xfrm>
+            <a:off x="5245608" y="2697480"/>
+            <a:ext cx="329184" cy="329184"/>
+          </a:xfrm>
+          <a:prstGeom prst="rect">
+            <a:avLst/>
+          </a:prstGeom>
+        </ns0:spPr>
+      </ns0:pic>
+      <ns0:sp>
+        <ns0:nvSpPr>
+          <ns0:cNvPr id="22" name="Text 18"/>
+          <ns0:cNvSpPr/>
+          <ns0:nvPr/>
+        </ns0:nvSpPr>
+        <ns0:spPr>
+          <a:xfrm>
+            <a:off x="3550920" y="2697480"/>
+            <a:ext cx="1722120" cy="310896"/>
+          </a:xfrm>
+          <a:prstGeom prst="rect">
+            <a:avLst/>
+          </a:prstGeom>
+          <a:noFill/>
+          <a:ln/>
+        </ns0:spPr>
+        <ns0:txBody>
+          <a:bodyPr wrap="square" lIns="0" tIns="0" rIns="0" bIns="0" rtlCol="0" anchor="ctr"/>
+          <a:lstStyle/>
+          <a:p>
+            <a:pPr marL="0" indent="0">
+              <a:buNone/>
+            </a:pPr>
+            <a:r>
+              <a:rPr lang="en-US" sz="1200" b="1" dirty="0">
+                <a:solidFill>
+                  <a:srgbClr val="0F1E3F"/>
+                </a:solidFill>
+                <a:latin typeface="Calibri" pitchFamily="34" charset="0"/>
+                <a:ea typeface="Calibri" pitchFamily="34" charset="-122"/>
+                <a:cs typeface="Calibri" pitchFamily="34" charset="-120"/>
+              </a:rPr>
+              <a:t>FGT(1) and FGT(2)</a:t>
+            </a:r>
+            <a:endParaRPr lang="en-US" sz="1200" dirty="0"/>
+          </a:p>
+        </ns0:txBody>
+      </ns0:sp>
+      <ns0:sp>
+        <ns0:nvSpPr>
+          <ns0:cNvPr id="23" name="Text 19"/>
+          <ns0:cNvSpPr/>
+          <ns0:nvPr/>
+        </ns0:nvSpPr>
+        <ns0:spPr>
+          <a:xfrm>
+            <a:off x="3550920" y="3108960"/>
+            <a:ext cx="2133600" cy="1280160"/>
+          </a:xfrm>
+          <a:prstGeom prst="rect">
+            <a:avLst/>
+          </a:prstGeom>
+          <a:noFill/>
+          <a:ln/>
+        </ns0:spPr>
+        <ns0:txBody>
+          <a:bodyPr wrap="square" lIns="0" tIns="0" rIns="0" bIns="0" rtlCol="0" anchor="ctr"/>
+          <a:lstStyle/>
+          <a:p>
+            <a:pPr marL="0" indent="0">
+              <a:buNone/>
+            </a:pPr>
+            <a:r>
+              <a:rPr lang="en-US" sz="1150" dirty="0">
+                <a:solidFill>
+                  <a:srgbClr val="43578A"/>
+                </a:solidFill>
+                <a:latin typeface="Calibri" pitchFamily="34" charset="0"/>
+                <a:ea typeface="Calibri" pitchFamily="34" charset="-122"/>
+                <a:cs typeface="Calibri" pitchFamily="34" charset="-120"/>
+              </a:rPr>
+              <a:t>Depth of poverty (average shortfall) and severity (more weight on the poorest).</a:t>
+            </a:r>
+            <a:endParaRPr lang="en-US" sz="1150" dirty="0"/>
+          </a:p>
+        </ns0:txBody>
+      </ns0:sp>
+      <ns0:sp>
+        <ns0:nvSpPr>
+          <ns0:cNvPr id="24" name="Shape 20"/>
+          <ns0:cNvSpPr/>
+          <ns0:nvPr/>
+        </ns0:nvSpPr>
+        <ns0:spPr>
+          <a:xfrm>
+            <a:off x="6050280" y="1828800"/>
+            <a:ext cx="2590800" cy="2743200"/>
+          </a:xfrm>
+          <a:prstGeom prst="rect">
+            <a:avLst/>
+          </a:prstGeom>
+          <a:solidFill>
+            <a:srgbClr val="FFFFFF"/>
+          </a:solidFill>
+          <a:ln w="9525">
+            <a:solidFill>
+              <a:srgbClr val="DCE4F0"/>
+            </a:solidFill>
+            <a:prstDash val="solid"/>
+          </a:ln>
+          <a:effectLst>
+            <a:outerShdw blurRad="76200" dist="12700" dir="5400000" algn="bl" rotWithShape="0">
+              <a:srgbClr val="1F3669">
+                <a:alpha val="5000"/>
+              </a:srgbClr>
+            </a:outerShdw>
+          </a:effectLst>
+        </ns0:spPr>
+        <ns0:txBody>
+          <a:bodyPr/>
+          <a:lstStyle/>
+          <a:p>
+            <a:endParaRPr lang="en-US"/>
+          </a:p>
+        </ns0:txBody>
+      </ns0:sp>
+      <ns0:sp>
+        <ns0:nvSpPr>
+          <ns0:cNvPr id="25" name="Shape 21"/>
+          <ns0:cNvSpPr/>
+          <ns0:nvPr/>
+        </ns0:nvSpPr>
+        <ns0:spPr>
+          <a:xfrm>
+            <a:off x="6050280" y="1828800"/>
+            <a:ext cx="2590800" cy="685800"/>
+          </a:xfrm>
+          <a:prstGeom prst="rect">
+            <a:avLst/>
+          </a:prstGeom>
+          <a:solidFill>
+            <a:srgbClr val="15284F"/>
+          </a:solidFill>
+          <a:ln w="12700">
+            <a:solidFill>
+              <a:srgbClr val="15284F"/>
+            </a:solidFill>
+            <a:prstDash val="solid"/>
+          </a:ln>
+        </ns0:spPr>
+        <ns0:txBody>
+          <a:bodyPr/>
+          <a:lstStyle/>
+          <a:p>
+            <a:endParaRPr lang="en-US"/>
+          </a:p>
+        </ns0:txBody>
+      </ns0:sp>
+      <ns0:sp>
+        <ns0:nvSpPr>
+          <ns0:cNvPr id="26" name="Text 22"/>
+          <ns0:cNvSpPr/>
+          <ns0:nvPr/>
+        </ns0:nvSpPr>
+        <ns0:spPr>
+          <a:xfrm>
+            <a:off x="6324600" y="1920240"/>
+            <a:ext cx="2133600" cy="228600"/>
+          </a:xfrm>
+          <a:prstGeom prst="rect">
+            <a:avLst/>
+          </a:prstGeom>
+          <a:noFill/>
+          <a:ln/>
+        </ns0:spPr>
+        <ns0:txBody>
+          <a:bodyPr wrap="square" lIns="0" tIns="0" rIns="0" bIns="0" rtlCol="0" anchor="ctr"/>
+          <a:lstStyle/>
+          <a:p>
+            <a:pPr marL="0" indent="0">
+              <a:buNone/>
+            </a:pPr>
+            <a:r>
+              <a:rPr lang="en-US" sz="1000" b="1" kern="0" spc="400" dirty="0">
+                <a:solidFill>
+                  <a:srgbClr val="6AA7D9"/>
+                </a:solidFill>
+                <a:latin typeface="Calibri" pitchFamily="34" charset="0"/>
+                <a:ea typeface="Calibri" pitchFamily="34" charset="-122"/>
+                <a:cs typeface="Calibri" pitchFamily="34" charset="-120"/>
+              </a:rPr>
+              <a:t>INDICATOR 3</a:t>
+            </a:r>
+            <a:endParaRPr lang="en-US" sz="1000" dirty="0"/>
+          </a:p>
+        </ns0:txBody>
+      </ns0:sp>
+      <ns0:sp>
+        <ns0:nvSpPr>
+          <ns0:cNvPr id="27" name="Text 23"/>
+          <ns0:cNvSpPr/>
+          <ns0:nvPr/>
+        </ns0:nvSpPr>
+        <ns0:spPr>
+          <a:xfrm>
+            <a:off x="6324600" y="2139696"/>
+            <a:ext cx="2133600" cy="310896"/>
+          </a:xfrm>
+          <a:prstGeom prst="rect">
+            <a:avLst/>
+          </a:prstGeom>
+          <a:noFill/>
+          <a:ln/>
+        </ns0:spPr>
+        <ns0:txBody>
+          <a:bodyPr wrap="square" lIns="0" tIns="0" rIns="0" bIns="0" rtlCol="0" anchor="ctr"/>
+          <a:lstStyle/>
+          <a:p>
+            <a:pPr marL="0" indent="0">
+              <a:buNone/>
+            </a:pPr>
+            <a:r>
+              <a:rPr lang="en-US" sz="1800" b="1" dirty="0">
+                <a:solidFill>
+                  <a:srgbClr val="FFFFFF"/>
+                </a:solidFill>
+                <a:latin typeface="Calibri" pitchFamily="34" charset="0"/>
+                <a:ea typeface="Calibri" pitchFamily="34" charset="-122"/>
+                <a:cs typeface="Calibri" pitchFamily="34" charset="-120"/>
+              </a:rPr>
+              <a:t>Mean welfare</a:t>
+            </a:r>
+            <a:endParaRPr lang="en-US" sz="1800" dirty="0"/>
+          </a:p>
+        </ns0:txBody>
+      </ns0:sp>
+      <ns0:pic>
+        <ns0:nvPicPr>
+          <ns0:cNvPr id="28" name="Image 2" descr="preencoded.png"/>
+          <ns0:cNvPicPr>
+            <a:picLocks noChangeAspect="1"/>
+          </ns0:cNvPicPr>
+          <ns0:nvPr/>
+        </ns0:nvPicPr>
+        <ns0:blipFill>
+          <a:blip ns2:embed="rId4"/>
+          <a:stretch>
+            <a:fillRect/>
+          </a:stretch>
+        </ns0:blipFill>
+        <ns0:spPr>
+          <a:xfrm>
+            <a:off x="8019288" y="2697480"/>
+            <a:ext cx="329184" cy="329184"/>
+          </a:xfrm>
+          <a:prstGeom prst="rect">
+            <a:avLst/>
+          </a:prstGeom>
+        </ns0:spPr>
+      </ns0:pic>
+      <ns0:sp>
+        <ns0:nvSpPr>
+          <ns0:cNvPr id="29" name="Text 24"/>
+          <ns0:cNvSpPr/>
+          <ns0:nvPr/>
+        </ns0:nvSpPr>
+        <ns0:spPr>
+          <a:xfrm>
+            <a:off x="6324600" y="2697480"/>
+            <a:ext cx="1722120" cy="310896"/>
+          </a:xfrm>
+          <a:prstGeom prst="rect">
+            <a:avLst/>
+          </a:prstGeom>
+          <a:noFill/>
+          <a:ln/>
+        </ns0:spPr>
+        <ns0:txBody>
+          <a:bodyPr wrap="square" lIns="0" tIns="0" rIns="0" bIns="0" rtlCol="0" anchor="ctr"/>
+          <a:lstStyle/>
+          <a:p>
+            <a:pPr marL="0" indent="0">
+              <a:buNone/>
+            </a:pPr>
+            <a:r>
+              <a:rPr lang="en-US" sz="1200" b="1" dirty="0">
+                <a:solidFill>
+                  <a:srgbClr val="0F1E3F"/>
+                </a:solidFill>
+                <a:latin typeface="Calibri" pitchFamily="34" charset="0"/>
+                <a:ea typeface="Calibri" pitchFamily="34" charset="-122"/>
+                <a:cs typeface="Calibri" pitchFamily="34" charset="-120"/>
+              </a:rPr>
+              <a:t>Income or consumption</a:t>
+            </a:r>
+            <a:endParaRPr lang="en-US" sz="1200" dirty="0"/>
+          </a:p>
+        </ns0:txBody>
+      </ns0:sp>
+      <ns0:sp>
+        <ns0:nvSpPr>
+          <ns0:cNvPr id="30" name="Text 25"/>
+          <ns0:cNvSpPr/>
+          <ns0:nvPr/>
+        </ns0:nvSpPr>
+        <ns0:spPr>
+          <a:xfrm>
+            <a:off x="6324600" y="3108960"/>
+            <a:ext cx="2133600" cy="1280160"/>
+          </a:xfrm>
+          <a:prstGeom prst="rect">
+            <a:avLst/>
+          </a:prstGeom>
+          <a:noFill/>
+          <a:ln/>
+        </ns0:spPr>
+        <ns0:txBody>
+          <a:bodyPr wrap="square" lIns="0" tIns="0" rIns="0" bIns="0" rtlCol="0" anchor="ctr"/>
+          <a:lstStyle/>
+          <a:p>
+            <a:pPr marL="0" indent="0">
+              <a:buNone/>
+            </a:pPr>
+            <a:r>
+              <a:rPr lang="en-US" sz="1150" dirty="0">
+                <a:solidFill>
+                  <a:srgbClr val="43578A"/>
+                </a:solidFill>
+                <a:latin typeface="Calibri" pitchFamily="34" charset="0"/>
+                <a:ea typeface="Calibri" pitchFamily="34" charset="-122"/>
+                <a:cs typeface="Calibri" pitchFamily="34" charset="-120"/>
+              </a:rPr>
+              <a:t>Population-weighted mean welfare, with an optional log scale and bias-corrected back-transform.</a:t>
+            </a:r>
+            <a:endParaRPr lang="en-US" sz="1150" dirty="0"/>
+          </a:p>
+        </ns0:txBody>
+      </ns0:sp>
+      <ns0:sp>
+        <ns0:nvSpPr>
+          <ns0:cNvPr id="31" name="Text 2">
+            <a:extLst>
+              <a:ext uri="{FF2B5EF4-FFF2-40B4-BE49-F238E27FC236}">
+                <ns3:creationId id="{A221DF0C-5EE4-40E9-8F00-5AD185154EEF}"/>
+              </a:ext>
+            </a:extLst>
+          </ns0:cNvPr>
+          <ns0:cNvSpPr/>
+          <ns0:nvPr/>
+        </ns0:nvSpPr>
+        <ns0:spPr>
+          <a:xfrm>
+            <a:off x="502920" y="347472"/>
+            <a:ext cx="6400800" cy="256032"/>
+          </a:xfrm>
+          <a:prstGeom prst="rect">
+            <a:avLst/>
+          </a:prstGeom>
+          <a:noFill/>
+          <a:ln/>
+        </ns0:spPr>
+        <ns0:txBody>
+          <a:bodyPr wrap="square" lIns="0" tIns="0" rIns="0" bIns="0" rtlCol="0" anchor="ctr"/>
+          <a:lstStyle/>
+          <a:p>
+            <a:pPr marL="0" indent="0">
+              <a:buNone/>
+            </a:pPr>
+            <a:r>
+              <a:rPr lang="en-US" sz="1000" b="1" kern="0" spc="600" dirty="0">
+                <a:solidFill>
+                  <a:srgbClr val="6AA7D9"/>
+                </a:solidFill>
+                <a:latin typeface="Calibri" pitchFamily="34" charset="0"/>
+                <a:ea typeface="Calibri" pitchFamily="34" charset="-122"/>
+                <a:cs typeface="Calibri" pitchFamily="34" charset="-120"/>
+              </a:rPr>
+              <a:t>OVERVIEW</a:t>
+            </a:r>
+            <a:endParaRPr lang="en-US" sz="1000" dirty="0"/>
+          </a:p>
+        </ns0:txBody>
+      </ns0:sp>
+    </ns0:spTree>
+    <ns0:extLst>
+      <ns0:ext uri="{BB962C8B-B14F-4D97-AF65-F5344CB8AC3E}">
+        <ns4:creationId val="234686998"/>
+      </ns0:ext>
+    </ns0:extLst>
   </ns0:cSld>
   <ns0:clrMapOvr>
     <a:masterClrMapping/>
@@ -29465,7 +30566,7 @@
                 <a:ea typeface="Calibri" pitchFamily="34" charset="-122"/>
                 <a:cs typeface="Calibri" pitchFamily="34" charset="-120"/>
               </a:rPr>
-              <a:t>4 / 29</a:t>
+              <a:t>5 / 30</a:t>
             </a:r>
             <a:endParaRPr lang="en-US" sz="900" dirty="0"/>
           </a:p>
@@ -30483,7 +31584,7 @@
                 <a:ea typeface="Calibri" pitchFamily="34" charset="-122"/>
                 <a:cs typeface="Calibri" pitchFamily="34" charset="-120"/>
               </a:rPr>
-              <a:t>5 / 29</a:t>
+              <a:t>6 / 30</a:t>
             </a:r>
             <a:endParaRPr lang="en-US" sz="900" dirty="0"/>
           </a:p>
@@ -31598,7 +32699,7 @@
                 <a:ea typeface="Calibri" pitchFamily="34" charset="-122"/>
                 <a:cs typeface="Calibri" pitchFamily="34" charset="-120"/>
               </a:rPr>
-              <a:t>6 / 29</a:t>
+              <a:t>7 / 30</a:t>
             </a:r>
             <a:endParaRPr lang="en-US" sz="900" dirty="0"/>
           </a:p>
@@ -32218,7 +33319,7 @@
                 <a:ea typeface="Calibri" pitchFamily="34" charset="-122"/>
                 <a:cs typeface="Calibri" pitchFamily="34" charset="-120"/>
               </a:rPr>
-              <a:t> </a:t>
+              <a:t xml:space="preserve"> </a:t>
             </a:r>
             <a:endParaRPr lang="en-US" sz="1200" dirty="0"/>
           </a:p>
@@ -32257,7 +33358,7 @@
                 <a:ea typeface="Calibri" pitchFamily="34" charset="-122"/>
                 <a:cs typeface="Calibri" pitchFamily="34" charset="-120"/>
               </a:rPr>
-              <a:t> </a:t>
+              <a:t xml:space="preserve"> </a:t>
             </a:r>
             <a:endParaRPr lang="en-US" sz="1200" dirty="0"/>
           </a:p>
@@ -33578,7 +34679,7 @@
                 <a:ea typeface="Calibri" pitchFamily="34" charset="-122"/>
                 <a:cs typeface="Calibri" pitchFamily="34" charset="-120"/>
               </a:rPr>
-              <a:t>That's it.  </a:t>
+              <a:t xml:space="preserve">That's it.  </a:t>
             </a:r>
             <a:r>
               <a:rPr lang="en-US" sz="1050" dirty="0">
@@ -33857,7 +34958,7 @@
                 <a:ea typeface="Calibri" pitchFamily="34" charset="-122"/>
                 <a:cs typeface="Calibri" pitchFamily="34" charset="-120"/>
               </a:rPr>
-              <a:t>7 / 29</a:t>
+              <a:t>8 / 30</a:t>
             </a:r>
             <a:endParaRPr lang="en-US" sz="900" dirty="0"/>
           </a:p>
@@ -34091,7 +35192,7 @@
                 <a:ea typeface="Calibri" pitchFamily="34" charset="-122"/>
                 <a:cs typeface="Calibri" pitchFamily="34" charset="-120"/>
               </a:rPr>
-              <a:t>8 / 29</a:t>
+              <a:t>9 / 30</a:t>
             </a:r>
             <a:endParaRPr lang="en-US" sz="900" dirty="0"/>
           </a:p>
@@ -35231,7 +36332,7 @@
                 <a:ea typeface="Calibri" pitchFamily="34" charset="-122"/>
                 <a:cs typeface="Calibri" pitchFamily="34" charset="-120"/>
               </a:rPr>
-              <a:t>9 / 29</a:t>
+              <a:t>10 / 30</a:t>
             </a:r>
             <a:endParaRPr lang="en-US" sz="900" dirty="0"/>
           </a:p>

</xml_diff>

<commit_message>
Update EU_SAE user guide PPTX
Replace instructions/EU_SAE_User_Guide_Dashboard_v2.pptx with an updated binary version. Remove the corresponding .inspect.ndjson file (instructions/EU_SAE_User_Guide_Dashboard_v2.pptx.inspect.ndjson), which appears to be a generated inspection artifact no longer needed.
</commit_message>
<xml_diff>
--- a/instructions/EU_SAE_User_Guide_Dashboard_v2.pptx
+++ b/instructions/EU_SAE_User_Guide_Dashboard_v2.pptx
@@ -5584,7 +5584,7 @@
                 <a:ea typeface="Calibri"/>
                 <a:cs typeface="Calibri"/>
               </a:rPr>
-              <a:t>You should see Start_Dashboard.bat, app.R, R/, scripts/, sample_data/, outputs/, instructions/, and www/.</a:t>
+              <a:t>You should see Start_Dashboard.bat, app.R, R/, scripts/, data/, outputs/, instructions/, and www/.</a:t>
             </a:r>
           </a:p>
         </p:txBody>
@@ -5763,7 +5763,7 @@
                 <a:ea typeface="Consolas"/>
                 <a:cs typeface="Consolas"/>
               </a:rPr>
-              <a:t>├── sample_data/</a:t>
+              <a:t>├── data/</a:t>
             </a:r>
           </a:p>
           <a:p xmlns:a="http://schemas.openxmlformats.org/drawingml/2006/main">
@@ -12327,7 +12327,7 @@
                 <a:ea typeface="Consolas"/>
                 <a:cs typeface="Consolas"/>
               </a:rPr>
-              <a:t>uploaded file or sample_data file</a:t>
+              <a:t>selected survey .rds from data/</a:t>
             </a:r>
           </a:p>
         </p:txBody>
@@ -12479,7 +12479,7 @@
                 <a:ea typeface="Consolas"/>
                 <a:cs typeface="Consolas"/>
               </a:rPr>
-              <a:t>uploaded geometry or sample_data geometry</a:t>
+              <a:t>choose geometry .rds from data/</a:t>
             </a:r>
           </a:p>
         </p:txBody>
@@ -18877,7 +18877,7 @@
                 <a:ea typeface="Calibri"/>
                 <a:cs typeface="Calibri"/>
               </a:rPr>
-              <a:t>Check Apply benchmarking in the sidebar. If unchecked, benchmark uploads and benchmark-level mappings are ignored.</a:t>
+              <a:t>Check Apply benchmarking. The target database and benchmark-level boxes appear only when this is checked.</a:t>
             </a:r>
           </a:p>
         </p:txBody>
@@ -29988,7 +29988,7 @@
                 <a:ea typeface="Calibri"/>
                 <a:cs typeface="Calibri"/>
               </a:rPr>
-              <a:t>File not found or missing default sample files</a:t>
+              <a:t>Data file not selected or not found</a:t>
             </a:r>
           </a:p>
         </p:txBody>
@@ -30033,7 +30033,7 @@
                 <a:ea typeface="Calibri"/>
                 <a:cs typeface="Calibri"/>
               </a:rPr>
-              <a:t>Make sure you extracted the full folder; if default files are missing, upload your own survey, auxiliary, and geometry files.</a:t>
+              <a:t>Put files in data/, then select the survey, auxiliary, and geometry .rds files in the dashboard. Extra files are OK.</a:t>
             </a:r>
           </a:p>
         </p:txBody>
@@ -35800,7 +35800,7 @@
                 <a:ea typeface="Calibri"/>
                 <a:cs typeface="Calibri"/>
               </a:rPr>
-              <a:t>Have these ready before you click Check Data Readiness.</a:t>
+              <a:t>Place the three .rds files in data/; extra files can remain there.</a:t>
             </a:r>
           </a:p>
         </p:txBody>
@@ -37646,7 +37646,7 @@
                 <a:ea typeface="Consolas"/>
                 <a:cs typeface="Consolas"/>
               </a:rPr>
-              <a:t>Prepare or upload your data files</a:t>
+              <a:t>Place data files in data/</a:t>
             </a:r>
           </a:p>
         </p:txBody>
@@ -38249,7 +38249,7 @@
                 <a:ea typeface="Calibri"/>
                 <a:cs typeface="Calibri"/>
               </a:rPr>
-              <a:t>Upload survey, auxiliary, and geometry files</a:t>
+              <a:t>Choose survey, auxiliary, and geometry files</a:t>
             </a:r>
           </a:p>
         </p:txBody>

</xml_diff>